<commit_message>
docs: rename slides - Borang Permohonan DPMM + Sistem Ahli DPMM
</commit_message>
<xml_diff>
--- a/LAPORAN-SISTEM-DPMM-JOHOR.pptx
+++ b/LAPORAN-SISTEM-DPMM-JOHOR.pptx
@@ -1476,7 +1476,7 @@
                 <a:ea typeface="Calibri" pitchFamily="34" charset="-122"/>
                 <a:cs typeface="Calibri" pitchFamily="34" charset="-120"/>
               </a:rPr>
-              <a:t>Borang Permohonan</a:t>
+              <a:t>Borang Permohonan DPMM</a:t>
             </a:r>
             <a:endParaRPr lang="en-US" sz="950" dirty="0"/>
           </a:p>
@@ -1542,7 +1542,7 @@
                 <a:ea typeface="Calibri" pitchFamily="34" charset="-122"/>
                 <a:cs typeface="Calibri" pitchFamily="34" charset="-120"/>
               </a:rPr>
-              <a:t>Sistem Ahli</a:t>
+              <a:t>Sistem Ahli DPMM</a:t>
             </a:r>
             <a:endParaRPr lang="en-US" sz="950" dirty="0"/>
           </a:p>
@@ -2064,7 +2064,7 @@
                 <a:ea typeface="Georgia" pitchFamily="34" charset="-122"/>
                 <a:cs typeface="Georgia" pitchFamily="34" charset="-120"/>
               </a:rPr>
-              <a:t>borang.html</a:t>
+              <a:t>Borang Permohonan DPMM</a:t>
             </a:r>
             <a:endParaRPr lang="en-US" sz="2800" dirty="0"/>
           </a:p>
@@ -2103,7 +2103,7 @@
                 <a:ea typeface="Calibri" pitchFamily="34" charset="-122"/>
                 <a:cs typeface="Calibri" pitchFamily="34" charset="-120"/>
               </a:rPr>
-              <a:t>Borang Permohonan Keahlian DPMM (Awam)</a:t>
+              <a:t>Borang Permohonan Keahlian — Akses Awam Tanpa Login</a:t>
             </a:r>
             <a:endParaRPr lang="en-US" sz="1200" dirty="0"/>
           </a:p>
@@ -4144,7 +4144,7 @@
                 <a:ea typeface="Georgia" pitchFamily="34" charset="-122"/>
                 <a:cs typeface="Georgia" pitchFamily="34" charset="-120"/>
               </a:rPr>
-              <a:t>index.html</a:t>
+              <a:t>Sistem Ahli DPMM</a:t>
             </a:r>
             <a:endParaRPr lang="en-US" sz="2800" dirty="0"/>
           </a:p>
@@ -4183,7 +4183,7 @@
                 <a:ea typeface="Calibri" pitchFamily="34" charset="-122"/>
                 <a:cs typeface="Calibri" pitchFamily="34" charset="-120"/>
               </a:rPr>
-              <a:t>SISTEM-AHLI — Panel Pengurusan Pentadbir (Login Diperlukan)</a:t>
+              <a:t>Panel Pengurusan Pentadbir — Login Diperlukan</a:t>
             </a:r>
             <a:endParaRPr lang="en-US" sz="1200" dirty="0"/>
           </a:p>

</xml_diff>